<commit_message>
Actualiza documentacion: Avance 02 alineado a rubrica
</commit_message>
<xml_diff>
--- a/docs/Presentacion_SysMarket_v2.pptx
+++ b/docs/Presentacion_SysMarket_v2.pptx
@@ -12508,6 +12508,13 @@
             <a:prstDash val="solid"/>
           </a:ln>
         </p:spPr>
+        <p:txBody>
+          <a:bodyPr/>
+          <a:lstStyle/>
+          <a:p>
+            <a:endParaRPr lang="es-PE" dirty="0"/>
+          </a:p>
+        </p:txBody>
       </p:sp>
       <p:sp>
         <p:nvSpPr>

</xml_diff>

<commit_message>
docs: README profesional y diagrama de arquitectura
</commit_message>
<xml_diff>
--- a/docs/Presentacion_SysMarket_v2.pptx
+++ b/docs/Presentacion_SysMarket_v2.pptx
@@ -5,7 +5,7 @@
     <p:sldMasterId id="2147483648" r:id="rId1"/>
   </p:sldMasterIdLst>
   <p:notesMasterIdLst>
-    <p:notesMasterId r:id="rId14"/>
+    <p:notesMasterId r:id="rId15"/>
   </p:notesMasterIdLst>
   <p:sldIdLst>
     <p:sldId id="256" r:id="rId2"/>
@@ -17,9 +17,10 @@
     <p:sldId id="262" r:id="rId8"/>
     <p:sldId id="263" r:id="rId9"/>
     <p:sldId id="264" r:id="rId10"/>
-    <p:sldId id="265" r:id="rId11"/>
-    <p:sldId id="266" r:id="rId12"/>
-    <p:sldId id="267" r:id="rId13"/>
+    <p:sldId id="268" r:id="rId11"/>
+    <p:sldId id="265" r:id="rId12"/>
+    <p:sldId id="266" r:id="rId13"/>
+    <p:sldId id="267" r:id="rId14"/>
   </p:sldIdLst>
   <p:sldSz cx="12192000" cy="6858000"/>
   <p:notesSz cx="6858000" cy="12192000"/>
@@ -406,7 +407,7 @@
     </p:spTree>
     <p:extLst>
       <p:ext uri="{BB962C8B-B14F-4D97-AF65-F5344CB8AC3E}">
-        <p14:creationId xmlns:p14="http://schemas.microsoft.com/office/powerpoint/2010/main" val="1024086991"/>
+        <p14:creationId xmlns:p14="http://schemas.microsoft.com/office/powerpoint/2010/main" val="1658282792"/>
       </p:ext>
     </p:extLst>
   </p:cSld>
@@ -566,6 +567,90 @@
             <a:fld id="{F7021451-1387-4CA6-816F-3879F97B5CBC}" type="slidenum">
               <a:rPr lang="en-US"/>
               <a:t>12</a:t>
+            </a:fld>
+            <a:endParaRPr lang="en-US"/>
+          </a:p>
+        </p:txBody>
+      </p:sp>
+    </p:spTree>
+    <p:extLst>
+      <p:ext uri="{BB962C8B-B14F-4D97-AF65-F5344CB8AC3E}">
+        <p14:creationId xmlns:p14="http://schemas.microsoft.com/office/powerpoint/2010/main" val="1024086991"/>
+      </p:ext>
+    </p:extLst>
+  </p:cSld>
+  <p:clrMapOvr>
+    <a:masterClrMapping/>
+  </p:clrMapOvr>
+</p:notes>
+</file>
+
+<file path=ppt/notesSlides/notesSlide13.xml><?xml version="1.0" encoding="utf-8"?>
+<p:notes xmlns:a="http://schemas.openxmlformats.org/drawingml/2006/main" xmlns:r="http://schemas.openxmlformats.org/officeDocument/2006/relationships" xmlns:p="http://schemas.openxmlformats.org/presentationml/2006/main">
+  <p:cSld>
+    <p:spTree>
+      <p:nvGrpSpPr>
+        <p:cNvPr id="1" name=""/>
+        <p:cNvGrpSpPr/>
+        <p:nvPr/>
+      </p:nvGrpSpPr>
+      <p:grpSpPr>
+        <a:xfrm>
+          <a:off x="0" y="0"/>
+          <a:ext cx="0" cy="0"/>
+          <a:chOff x="0" y="0"/>
+          <a:chExt cx="0" cy="0"/>
+        </a:xfrm>
+      </p:grpSpPr>
+      <p:sp>
+        <p:nvSpPr>
+          <p:cNvPr id="2" name="Slide Image Placeholder 1"/>
+          <p:cNvSpPr>
+            <a:spLocks noGrp="1" noRot="1" noChangeAspect="1"/>
+          </p:cNvSpPr>
+          <p:nvPr>
+            <p:ph type="sldImg"/>
+          </p:nvPr>
+        </p:nvSpPr>
+        <p:spPr/>
+      </p:sp>
+      <p:sp>
+        <p:nvSpPr>
+          <p:cNvPr id="3" name="Notes Placeholder 2"/>
+          <p:cNvSpPr>
+            <a:spLocks noGrp="1"/>
+          </p:cNvSpPr>
+          <p:nvPr>
+            <p:ph type="body" idx="1"/>
+          </p:nvPr>
+        </p:nvSpPr>
+        <p:spPr/>
+        <p:txBody>
+          <a:bodyPr/>
+          <a:lstStyle/>
+          <a:p>
+            <a:endParaRPr lang="en-US" dirty="0"/>
+          </a:p>
+        </p:txBody>
+      </p:sp>
+      <p:sp>
+        <p:nvSpPr>
+          <p:cNvPr id="4" name="Slide Number Placeholder 3"/>
+          <p:cNvSpPr>
+            <a:spLocks noGrp="1"/>
+          </p:cNvSpPr>
+          <p:nvPr>
+            <p:ph type="sldNum" sz="quarter" idx="10"/>
+          </p:nvPr>
+        </p:nvSpPr>
+        <p:spPr/>
+        <p:txBody>
+          <a:bodyPr/>
+          <a:lstStyle/>
+          <a:p>
+            <a:fld id="{F7021451-1387-4CA6-816F-3879F97B5CBC}" type="slidenum">
+              <a:rPr lang="en-US"/>
+              <a:t>13</a:t>
             </a:fld>
             <a:endParaRPr lang="en-US"/>
           </a:p>
@@ -2006,6 +2091,232 @@
 
 <file path=ppt/slides/slide10.xml><?xml version="1.0" encoding="utf-8"?>
 <p:sld xmlns:a="http://schemas.openxmlformats.org/drawingml/2006/main" xmlns:r="http://schemas.openxmlformats.org/officeDocument/2006/relationships" xmlns:p="http://schemas.openxmlformats.org/presentationml/2006/main">
+  <p:cSld>
+    <p:bg>
+      <p:bgPr>
+        <a:solidFill>
+          <a:srgbClr val="060914"/>
+        </a:solidFill>
+        <a:effectLst/>
+      </p:bgPr>
+    </p:bg>
+    <p:spTree>
+      <p:nvGrpSpPr>
+        <p:cNvPr id="1" name=""/>
+        <p:cNvGrpSpPr/>
+        <p:nvPr/>
+      </p:nvGrpSpPr>
+      <p:grpSpPr>
+        <a:xfrm>
+          <a:off x="0" y="0"/>
+          <a:ext cx="0" cy="0"/>
+          <a:chOff x="0" y="0"/>
+          <a:chExt cx="0" cy="0"/>
+        </a:xfrm>
+      </p:grpSpPr>
+      <p:sp>
+        <p:nvSpPr>
+          <p:cNvPr id="2" name="Shape 0"/>
+          <p:cNvSpPr/>
+          <p:nvPr/>
+        </p:nvSpPr>
+        <p:spPr>
+          <a:xfrm>
+            <a:off x="-1828800" y="-1828800"/>
+            <a:ext cx="4572000" cy="4572000"/>
+          </a:xfrm>
+          <a:prstGeom prst="ellipse">
+            <a:avLst/>
+          </a:prstGeom>
+          <a:solidFill>
+            <a:srgbClr val="3B82F6">
+              <a:alpha val="20000"/>
+            </a:srgbClr>
+          </a:solidFill>
+          <a:ln w="12700">
+            <a:solidFill>
+              <a:srgbClr val="3B82F6">
+                <a:alpha val="0"/>
+              </a:srgbClr>
+            </a:solidFill>
+            <a:prstDash val="solid"/>
+          </a:ln>
+        </p:spPr>
+      </p:sp>
+      <p:sp>
+        <p:nvSpPr>
+          <p:cNvPr id="3" name="Shape 1"/>
+          <p:cNvSpPr/>
+          <p:nvPr/>
+        </p:nvSpPr>
+        <p:spPr>
+          <a:xfrm>
+            <a:off x="8780828" y="-800100"/>
+            <a:ext cx="3657600" cy="3657600"/>
+          </a:xfrm>
+          <a:prstGeom prst="ellipse">
+            <a:avLst/>
+          </a:prstGeom>
+          <a:solidFill>
+            <a:srgbClr val="8B5CF6">
+              <a:alpha val="15000"/>
+            </a:srgbClr>
+          </a:solidFill>
+          <a:ln w="12700">
+            <a:solidFill>
+              <a:srgbClr val="8B5CF6">
+                <a:alpha val="0"/>
+              </a:srgbClr>
+            </a:solidFill>
+            <a:prstDash val="solid"/>
+          </a:ln>
+        </p:spPr>
+      </p:sp>
+      <p:sp>
+        <p:nvSpPr>
+          <p:cNvPr id="4" name="Shape 2"/>
+          <p:cNvSpPr/>
+          <p:nvPr/>
+        </p:nvSpPr>
+        <p:spPr>
+          <a:xfrm>
+            <a:off x="457200" y="411480"/>
+            <a:ext cx="2286000" cy="320040"/>
+          </a:xfrm>
+          <a:prstGeom prst="roundRect">
+            <a:avLst>
+              <a:gd name="adj" fmla="val 48571"/>
+            </a:avLst>
+          </a:prstGeom>
+          <a:solidFill>
+            <a:srgbClr val="3B82F6">
+              <a:alpha val="20000"/>
+            </a:srgbClr>
+          </a:solidFill>
+          <a:ln w="6350">
+            <a:solidFill>
+              <a:srgbClr val="3B82F6"/>
+            </a:solidFill>
+            <a:prstDash val="solid"/>
+          </a:ln>
+        </p:spPr>
+      </p:sp>
+      <p:sp>
+        <p:nvSpPr>
+          <p:cNvPr id="43" name="Shape 41"/>
+          <p:cNvSpPr/>
+          <p:nvPr/>
+        </p:nvSpPr>
+        <p:spPr>
+          <a:xfrm>
+            <a:off x="10332720" y="3063240"/>
+            <a:ext cx="1554480" cy="91440"/>
+          </a:xfrm>
+          <a:prstGeom prst="rect">
+            <a:avLst/>
+          </a:prstGeom>
+          <a:solidFill>
+            <a:srgbClr val="060914"/>
+          </a:solidFill>
+          <a:ln w="12700">
+            <a:solidFill>
+              <a:srgbClr val="060914"/>
+            </a:solidFill>
+            <a:prstDash val="solid"/>
+          </a:ln>
+        </p:spPr>
+      </p:sp>
+      <p:sp>
+        <p:nvSpPr>
+          <p:cNvPr id="90" name="Text 88"/>
+          <p:cNvSpPr/>
+          <p:nvPr/>
+        </p:nvSpPr>
+        <p:spPr>
+          <a:xfrm>
+            <a:off x="457200" y="6492240"/>
+            <a:ext cx="5486400" cy="274320"/>
+          </a:xfrm>
+          <a:prstGeom prst="rect">
+            <a:avLst/>
+          </a:prstGeom>
+          <a:noFill/>
+          <a:ln/>
+        </p:spPr>
+        <p:txBody>
+          <a:bodyPr wrap="square" rtlCol="0" anchor="ctr"/>
+          <a:lstStyle/>
+          <a:p>
+            <a:pPr marL="0" indent="0">
+              <a:buNone/>
+            </a:pPr>
+            <a:r>
+              <a:rPr lang="en-US" sz="900" dirty="0">
+                <a:solidFill>
+                  <a:srgbClr val="94A3B8"/>
+                </a:solidFill>
+                <a:latin typeface="Calibri" pitchFamily="34" charset="0"/>
+                <a:ea typeface="Calibri" pitchFamily="34" charset="-122"/>
+                <a:cs typeface="Calibri" pitchFamily="34" charset="-120"/>
+              </a:rPr>
+              <a:t>SysMarket v2 · Grupo 1 · USIL 2026</a:t>
+            </a:r>
+            <a:endParaRPr lang="en-US" sz="900" dirty="0"/>
+          </a:p>
+        </p:txBody>
+      </p:sp>
+      <p:sp>
+        <p:nvSpPr>
+          <p:cNvPr id="91" name="Text 89"/>
+          <p:cNvSpPr/>
+          <p:nvPr/>
+        </p:nvSpPr>
+        <p:spPr>
+          <a:xfrm>
+            <a:off x="11338560" y="6492240"/>
+            <a:ext cx="457200" cy="274320"/>
+          </a:xfrm>
+          <a:prstGeom prst="rect">
+            <a:avLst/>
+          </a:prstGeom>
+          <a:noFill/>
+          <a:ln/>
+        </p:spPr>
+        <p:txBody>
+          <a:bodyPr wrap="square" rtlCol="0" anchor="ctr"/>
+          <a:lstStyle/>
+          <a:p>
+            <a:pPr marL="0" indent="0" algn="r">
+              <a:buNone/>
+            </a:pPr>
+            <a:r>
+              <a:rPr lang="en-US" sz="900" dirty="0">
+                <a:solidFill>
+                  <a:srgbClr val="94A3B8"/>
+                </a:solidFill>
+                <a:latin typeface="Consolas" pitchFamily="34" charset="0"/>
+              </a:rPr>
+              <a:t>10</a:t>
+            </a:r>
+            <a:endParaRPr lang="en-US" sz="900" dirty="0"/>
+          </a:p>
+        </p:txBody>
+      </p:sp>
+    </p:spTree>
+    <p:extLst>
+      <p:ext uri="{BB962C8B-B14F-4D97-AF65-F5344CB8AC3E}">
+        <p14:creationId xmlns:p14="http://schemas.microsoft.com/office/powerpoint/2010/main" val="2167528628"/>
+      </p:ext>
+    </p:extLst>
+  </p:cSld>
+  <p:clrMapOvr>
+    <a:masterClrMapping/>
+  </p:clrMapOvr>
+</p:sld>
+</file>
+
+<file path=ppt/slides/slide11.xml><?xml version="1.0" encoding="utf-8"?>
+<p:sld xmlns:a="http://schemas.openxmlformats.org/drawingml/2006/main" xmlns:r="http://schemas.openxmlformats.org/officeDocument/2006/relationships" xmlns:p="http://schemas.openxmlformats.org/presentationml/2006/main">
   <p:cSld name="Slide 10">
     <p:bg>
       <p:bgPr>
@@ -2959,7 +3270,7 @@
                 <a:ea typeface="Consolas" pitchFamily="34" charset="-122"/>
                 <a:cs typeface="Consolas" pitchFamily="34" charset="-120"/>
               </a:rPr>
-              <a:t>10</a:t>
+              <a:t>11</a:t>
             </a:r>
             <a:endParaRPr lang="en-US" sz="900" dirty="0"/>
           </a:p>
@@ -2973,7 +3284,7 @@
 </p:sld>
 </file>
 
-<file path=ppt/slides/slide11.xml><?xml version="1.0" encoding="utf-8"?>
+<file path=ppt/slides/slide12.xml><?xml version="1.0" encoding="utf-8"?>
 <p:sld xmlns:a="http://schemas.openxmlformats.org/drawingml/2006/main" xmlns:r="http://schemas.openxmlformats.org/officeDocument/2006/relationships" xmlns:p="http://schemas.openxmlformats.org/presentationml/2006/main">
   <p:cSld name="Slide 11">
     <p:bg>
@@ -3803,7 +4114,7 @@
                 <a:ea typeface="Consolas" pitchFamily="34" charset="-122"/>
                 <a:cs typeface="Consolas" pitchFamily="34" charset="-120"/>
               </a:rPr>
-              <a:t>11</a:t>
+              <a:t>12</a:t>
             </a:r>
             <a:endParaRPr lang="en-US" sz="900" dirty="0"/>
           </a:p>
@@ -3817,7 +4128,7 @@
 </p:sld>
 </file>
 
-<file path=ppt/slides/slide12.xml><?xml version="1.0" encoding="utf-8"?>
+<file path=ppt/slides/slide13.xml><?xml version="1.0" encoding="utf-8"?>
 <p:sld xmlns:a="http://schemas.openxmlformats.org/drawingml/2006/main" xmlns:r="http://schemas.openxmlformats.org/officeDocument/2006/relationships" xmlns:p="http://schemas.openxmlformats.org/presentationml/2006/main">
   <p:cSld name="Slide 12">
     <p:bg>
@@ -5689,6 +6000,35 @@
           <a:chExt cx="0" cy="0"/>
         </a:xfrm>
       </p:grpSpPr>
+      <p:pic>
+        <p:nvPicPr>
+          <p:cNvPr id="35" name="Imagen 34">
+            <a:extLst>
+              <a:ext uri="{FF2B5EF4-FFF2-40B4-BE49-F238E27FC236}">
+                <a16:creationId xmlns:a16="http://schemas.microsoft.com/office/drawing/2014/main" id="{C4534040-96A3-4EE0-B2B1-3C58D0DB35F4}"/>
+              </a:ext>
+            </a:extLst>
+          </p:cNvPr>
+          <p:cNvPicPr>
+            <a:picLocks noChangeAspect="1"/>
+          </p:cNvPicPr>
+          <p:nvPr/>
+        </p:nvPicPr>
+        <p:blipFill rotWithShape="1">
+          <a:blip r:embed="rId3"/>
+          <a:srcRect b="4538"/>
+          <a:stretch/>
+        </p:blipFill>
+        <p:spPr>
+          <a:xfrm>
+            <a:off x="1106457" y="351434"/>
+            <a:ext cx="9979086" cy="6211292"/>
+          </a:xfrm>
+          <a:prstGeom prst="rect">
+            <a:avLst/>
+          </a:prstGeom>
+        </p:spPr>
+      </p:pic>
       <p:sp>
         <p:nvSpPr>
           <p:cNvPr id="2" name="Shape 0"/>
@@ -5697,7 +6037,7 @@
         </p:nvSpPr>
         <p:spPr>
           <a:xfrm>
-            <a:off x="-1828800" y="-1828800"/>
+            <a:off x="-2426179" y="-1714500"/>
             <a:ext cx="4572000" cy="4572000"/>
           </a:xfrm>
           <a:prstGeom prst="ellipse">
@@ -5717,6 +6057,13 @@
             <a:prstDash val="solid"/>
           </a:ln>
         </p:spPr>
+        <p:txBody>
+          <a:bodyPr/>
+          <a:lstStyle/>
+          <a:p>
+            <a:endParaRPr lang="es-PE" dirty="0"/>
+          </a:p>
+        </p:txBody>
       </p:sp>
       <p:sp>
         <p:nvSpPr>
@@ -5726,7 +6073,7 @@
         </p:nvSpPr>
         <p:spPr>
           <a:xfrm>
-            <a:off x="8686800" y="-914400"/>
+            <a:off x="9738360" y="-1280160"/>
             <a:ext cx="3657600" cy="3657600"/>
           </a:xfrm>
           <a:prstGeom prst="ellipse">
@@ -5755,7 +6102,7 @@
         </p:nvSpPr>
         <p:spPr>
           <a:xfrm>
-            <a:off x="457200" y="411480"/>
+            <a:off x="509078" y="411480"/>
             <a:ext cx="2286000" cy="320040"/>
           </a:xfrm>
           <a:prstGeom prst="roundRect">
@@ -5775,6 +6122,13 @@
             <a:prstDash val="solid"/>
           </a:ln>
         </p:spPr>
+        <p:txBody>
+          <a:bodyPr/>
+          <a:lstStyle/>
+          <a:p>
+            <a:endParaRPr lang="es-PE" dirty="0"/>
+          </a:p>
+        </p:txBody>
       </p:sp>
       <p:sp>
         <p:nvSpPr>
@@ -5812,931 +6166,6 @@
               <a:t>03 · ARQUITECTURA</a:t>
             </a:r>
             <a:endParaRPr lang="en-US" sz="1000" dirty="0"/>
-          </a:p>
-        </p:txBody>
-      </p:sp>
-      <p:sp>
-        <p:nvSpPr>
-          <p:cNvPr id="6" name="Text 4"/>
-          <p:cNvSpPr/>
-          <p:nvPr/>
-        </p:nvSpPr>
-        <p:spPr>
-          <a:xfrm>
-            <a:off x="457200" y="822960"/>
-            <a:ext cx="10972800" cy="640080"/>
-          </a:xfrm>
-          <a:prstGeom prst="rect">
-            <a:avLst/>
-          </a:prstGeom>
-          <a:noFill/>
-          <a:ln/>
-        </p:spPr>
-        <p:txBody>
-          <a:bodyPr wrap="square" rtlCol="0" anchor="ctr"/>
-          <a:lstStyle/>
-          <a:p>
-            <a:pPr marL="0" indent="0">
-              <a:buNone/>
-            </a:pPr>
-            <a:r>
-              <a:rPr lang="en-US" sz="3600" b="1" kern="0" spc="-100" dirty="0">
-                <a:solidFill>
-                  <a:srgbClr val="FFFFFF"/>
-                </a:solidFill>
-                <a:latin typeface="Calibri" pitchFamily="34" charset="0"/>
-                <a:ea typeface="Calibri" pitchFamily="34" charset="-122"/>
-                <a:cs typeface="Calibri" pitchFamily="34" charset="-120"/>
-              </a:rPr>
-              <a:t>Tres contenedores Docker sobre AWS EC2</a:t>
-            </a:r>
-            <a:endParaRPr lang="en-US" sz="3600" dirty="0"/>
-          </a:p>
-        </p:txBody>
-      </p:sp>
-      <p:sp>
-        <p:nvSpPr>
-          <p:cNvPr id="7" name="Shape 5"/>
-          <p:cNvSpPr/>
-          <p:nvPr/>
-        </p:nvSpPr>
-        <p:spPr>
-          <a:xfrm>
-            <a:off x="457200" y="1828800"/>
-            <a:ext cx="11247120" cy="4023360"/>
-          </a:xfrm>
-          <a:prstGeom prst="roundRect">
-            <a:avLst>
-              <a:gd name="adj" fmla="val 3409"/>
-            </a:avLst>
-          </a:prstGeom>
-          <a:solidFill>
-            <a:srgbClr val="0B1224"/>
-          </a:solidFill>
-          <a:ln w="12700">
-            <a:solidFill>
-              <a:srgbClr val="3B82F6"/>
-            </a:solidFill>
-            <a:prstDash val="dash"/>
-          </a:ln>
-        </p:spPr>
-      </p:sp>
-      <p:sp>
-        <p:nvSpPr>
-          <p:cNvPr id="8" name="Text 6"/>
-          <p:cNvSpPr/>
-          <p:nvPr/>
-        </p:nvSpPr>
-        <p:spPr>
-          <a:xfrm>
-            <a:off x="640080" y="1920240"/>
-            <a:ext cx="4572000" cy="320040"/>
-          </a:xfrm>
-          <a:prstGeom prst="rect">
-            <a:avLst/>
-          </a:prstGeom>
-          <a:noFill/>
-          <a:ln/>
-        </p:spPr>
-        <p:txBody>
-          <a:bodyPr wrap="square" rtlCol="0" anchor="ctr"/>
-          <a:lstStyle/>
-          <a:p>
-            <a:pPr marL="0" indent="0">
-              <a:buNone/>
-            </a:pPr>
-            <a:r>
-              <a:rPr lang="en-US" sz="1100" b="1" dirty="0">
-                <a:solidFill>
-                  <a:srgbClr val="3B82F6"/>
-                </a:solidFill>
-                <a:latin typeface="Consolas" pitchFamily="34" charset="0"/>
-                <a:ea typeface="Consolas" pitchFamily="34" charset="-122"/>
-                <a:cs typeface="Consolas" pitchFamily="34" charset="-120"/>
-              </a:rPr>
-              <a:t>AWS EC2 t2.micro · Ubuntu 22.04 LTS</a:t>
-            </a:r>
-            <a:endParaRPr lang="en-US" sz="1100" dirty="0"/>
-          </a:p>
-        </p:txBody>
-      </p:sp>
-      <p:sp>
-        <p:nvSpPr>
-          <p:cNvPr id="9" name="Shape 7"/>
-          <p:cNvSpPr/>
-          <p:nvPr/>
-        </p:nvSpPr>
-        <p:spPr>
-          <a:xfrm>
-            <a:off x="777240" y="2331720"/>
-            <a:ext cx="10607040" cy="3383280"/>
-          </a:xfrm>
-          <a:prstGeom prst="roundRect">
-            <a:avLst>
-              <a:gd name="adj" fmla="val 3243"/>
-            </a:avLst>
-          </a:prstGeom>
-          <a:solidFill>
-            <a:srgbClr val="131C33"/>
-          </a:solidFill>
-          <a:ln w="12700">
-            <a:solidFill>
-              <a:srgbClr val="233156"/>
-            </a:solidFill>
-            <a:prstDash val="solid"/>
-          </a:ln>
-        </p:spPr>
-      </p:sp>
-      <p:sp>
-        <p:nvSpPr>
-          <p:cNvPr id="10" name="Text 8"/>
-          <p:cNvSpPr/>
-          <p:nvPr/>
-        </p:nvSpPr>
-        <p:spPr>
-          <a:xfrm>
-            <a:off x="960120" y="2423160"/>
-            <a:ext cx="4572000" cy="274320"/>
-          </a:xfrm>
-          <a:prstGeom prst="rect">
-            <a:avLst/>
-          </a:prstGeom>
-          <a:noFill/>
-          <a:ln/>
-        </p:spPr>
-        <p:txBody>
-          <a:bodyPr wrap="square" rtlCol="0" anchor="ctr"/>
-          <a:lstStyle/>
-          <a:p>
-            <a:pPr marL="0" indent="0">
-              <a:buNone/>
-            </a:pPr>
-            <a:r>
-              <a:rPr lang="en-US" sz="900" dirty="0">
-                <a:solidFill>
-                  <a:srgbClr val="94A3B8"/>
-                </a:solidFill>
-                <a:latin typeface="Consolas" pitchFamily="34" charset="0"/>
-                <a:ea typeface="Consolas" pitchFamily="34" charset="-122"/>
-                <a:cs typeface="Consolas" pitchFamily="34" charset="-120"/>
-              </a:rPr>
-              <a:t>Docker network: sysmarket_net</a:t>
-            </a:r>
-            <a:endParaRPr lang="en-US" sz="900" dirty="0"/>
-          </a:p>
-        </p:txBody>
-      </p:sp>
-      <p:sp>
-        <p:nvSpPr>
-          <p:cNvPr id="11" name="Shape 9"/>
-          <p:cNvSpPr/>
-          <p:nvPr/>
-        </p:nvSpPr>
-        <p:spPr>
-          <a:xfrm>
-            <a:off x="1097280" y="2834640"/>
-            <a:ext cx="3017520" cy="2651760"/>
-          </a:xfrm>
-          <a:prstGeom prst="roundRect">
-            <a:avLst>
-              <a:gd name="adj" fmla="val 5172"/>
-            </a:avLst>
-          </a:prstGeom>
-          <a:solidFill>
-            <a:srgbClr val="0B1224"/>
-          </a:solidFill>
-          <a:ln w="25400">
-            <a:solidFill>
-              <a:srgbClr val="06B6D4"/>
-            </a:solidFill>
-            <a:prstDash val="solid"/>
-          </a:ln>
-        </p:spPr>
-      </p:sp>
-      <p:sp>
-        <p:nvSpPr>
-          <p:cNvPr id="12" name="Shape 10"/>
-          <p:cNvSpPr/>
-          <p:nvPr/>
-        </p:nvSpPr>
-        <p:spPr>
-          <a:xfrm>
-            <a:off x="1280160" y="3017520"/>
-            <a:ext cx="457200" cy="457200"/>
-          </a:xfrm>
-          <a:prstGeom prst="ellipse">
-            <a:avLst/>
-          </a:prstGeom>
-          <a:solidFill>
-            <a:srgbClr val="06B6D4">
-              <a:alpha val="30000"/>
-            </a:srgbClr>
-          </a:solidFill>
-          <a:ln w="12700">
-            <a:solidFill>
-              <a:srgbClr val="06B6D4"/>
-            </a:solidFill>
-            <a:prstDash val="solid"/>
-          </a:ln>
-        </p:spPr>
-      </p:sp>
-      <p:sp>
-        <p:nvSpPr>
-          <p:cNvPr id="13" name="Text 11"/>
-          <p:cNvSpPr/>
-          <p:nvPr/>
-        </p:nvSpPr>
-        <p:spPr>
-          <a:xfrm>
-            <a:off x="1874520" y="3017520"/>
-            <a:ext cx="2194560" cy="365760"/>
-          </a:xfrm>
-          <a:prstGeom prst="rect">
-            <a:avLst/>
-          </a:prstGeom>
-          <a:noFill/>
-          <a:ln/>
-        </p:spPr>
-        <p:txBody>
-          <a:bodyPr wrap="square" rtlCol="0" anchor="ctr"/>
-          <a:lstStyle/>
-          <a:p>
-            <a:pPr marL="0" indent="0">
-              <a:buNone/>
-            </a:pPr>
-            <a:r>
-              <a:rPr lang="en-US" sz="1600" b="1" dirty="0">
-                <a:solidFill>
-                  <a:srgbClr val="06B6D4"/>
-                </a:solidFill>
-                <a:latin typeface="Consolas" pitchFamily="34" charset="0"/>
-                <a:ea typeface="Consolas" pitchFamily="34" charset="-122"/>
-                <a:cs typeface="Consolas" pitchFamily="34" charset="-120"/>
-              </a:rPr>
-              <a:t>apache-php</a:t>
-            </a:r>
-            <a:endParaRPr lang="en-US" sz="1600" dirty="0"/>
-          </a:p>
-        </p:txBody>
-      </p:sp>
-      <p:sp>
-        <p:nvSpPr>
-          <p:cNvPr id="14" name="Text 12"/>
-          <p:cNvSpPr/>
-          <p:nvPr/>
-        </p:nvSpPr>
-        <p:spPr>
-          <a:xfrm>
-            <a:off x="1280160" y="3520440"/>
-            <a:ext cx="2743200" cy="274320"/>
-          </a:xfrm>
-          <a:prstGeom prst="rect">
-            <a:avLst/>
-          </a:prstGeom>
-          <a:noFill/>
-          <a:ln/>
-        </p:spPr>
-        <p:txBody>
-          <a:bodyPr wrap="square" rtlCol="0" anchor="ctr"/>
-          <a:lstStyle/>
-          <a:p>
-            <a:pPr marL="0" indent="0">
-              <a:buNone/>
-            </a:pPr>
-            <a:r>
-              <a:rPr lang="en-US" sz="1100" dirty="0">
-                <a:solidFill>
-                  <a:srgbClr val="E2E8F0"/>
-                </a:solidFill>
-                <a:latin typeface="Calibri" pitchFamily="34" charset="0"/>
-                <a:ea typeface="Calibri" pitchFamily="34" charset="-122"/>
-                <a:cs typeface="Calibri" pitchFamily="34" charset="-120"/>
-              </a:rPr>
-              <a:t>PHP 8.2 + Apache</a:t>
-            </a:r>
-            <a:endParaRPr lang="en-US" sz="1100" dirty="0"/>
-          </a:p>
-        </p:txBody>
-      </p:sp>
-      <p:sp>
-        <p:nvSpPr>
-          <p:cNvPr id="15" name="Text 13"/>
-          <p:cNvSpPr/>
-          <p:nvPr/>
-        </p:nvSpPr>
-        <p:spPr>
-          <a:xfrm>
-            <a:off x="1280160" y="3840480"/>
-            <a:ext cx="2743200" cy="1097280"/>
-          </a:xfrm>
-          <a:prstGeom prst="rect">
-            <a:avLst/>
-          </a:prstGeom>
-          <a:noFill/>
-          <a:ln/>
-        </p:spPr>
-        <p:txBody>
-          <a:bodyPr wrap="square" rtlCol="0" anchor="ctr"/>
-          <a:lstStyle/>
-          <a:p>
-            <a:pPr marL="0" indent="0">
-              <a:buNone/>
-            </a:pPr>
-            <a:r>
-              <a:rPr lang="en-US" sz="1100" dirty="0">
-                <a:solidFill>
-                  <a:srgbClr val="94A3B8"/>
-                </a:solidFill>
-                <a:latin typeface="Calibri" pitchFamily="34" charset="0"/>
-                <a:ea typeface="Calibri" pitchFamily="34" charset="-122"/>
-                <a:cs typeface="Calibri" pitchFamily="34" charset="-120"/>
-              </a:rPr>
-              <a:t>Tienda, carrito,</a:t>
-            </a:r>
-            <a:endParaRPr lang="en-US" sz="1100" dirty="0"/>
-          </a:p>
-          <a:p>
-            <a:pPr marL="0" indent="0">
-              <a:buNone/>
-            </a:pPr>
-            <a:r>
-              <a:rPr lang="en-US" sz="1100" dirty="0">
-                <a:solidFill>
-                  <a:srgbClr val="94A3B8"/>
-                </a:solidFill>
-                <a:latin typeface="Calibri" pitchFamily="34" charset="0"/>
-                <a:ea typeface="Calibri" pitchFamily="34" charset="-122"/>
-                <a:cs typeface="Calibri" pitchFamily="34" charset="-120"/>
-              </a:rPr>
-              <a:t>checkout, monitor UI</a:t>
-            </a:r>
-            <a:endParaRPr lang="en-US" sz="1100" dirty="0"/>
-          </a:p>
-        </p:txBody>
-      </p:sp>
-      <p:sp>
-        <p:nvSpPr>
-          <p:cNvPr id="16" name="Text 14"/>
-          <p:cNvSpPr/>
-          <p:nvPr/>
-        </p:nvSpPr>
-        <p:spPr>
-          <a:xfrm>
-            <a:off x="1280160" y="5074920"/>
-            <a:ext cx="2743200" cy="274320"/>
-          </a:xfrm>
-          <a:prstGeom prst="rect">
-            <a:avLst/>
-          </a:prstGeom>
-          <a:noFill/>
-          <a:ln/>
-        </p:spPr>
-        <p:txBody>
-          <a:bodyPr wrap="square" rtlCol="0" anchor="ctr"/>
-          <a:lstStyle/>
-          <a:p>
-            <a:pPr marL="0" indent="0">
-              <a:buNone/>
-            </a:pPr>
-            <a:r>
-              <a:rPr lang="en-US" sz="1000" i="1" dirty="0">
-                <a:solidFill>
-                  <a:srgbClr val="06B6D4"/>
-                </a:solidFill>
-                <a:latin typeface="Consolas" pitchFamily="34" charset="0"/>
-                <a:ea typeface="Consolas" pitchFamily="34" charset="-122"/>
-                <a:cs typeface="Consolas" pitchFamily="34" charset="-120"/>
-              </a:rPr>
-              <a:t>:80 → afuera</a:t>
-            </a:r>
-            <a:endParaRPr lang="en-US" sz="1000" dirty="0"/>
-          </a:p>
-        </p:txBody>
-      </p:sp>
-      <p:sp>
-        <p:nvSpPr>
-          <p:cNvPr id="17" name="Shape 15"/>
-          <p:cNvSpPr/>
-          <p:nvPr/>
-        </p:nvSpPr>
-        <p:spPr>
-          <a:xfrm>
-            <a:off x="4846320" y="2834640"/>
-            <a:ext cx="3017520" cy="2651760"/>
-          </a:xfrm>
-          <a:prstGeom prst="roundRect">
-            <a:avLst>
-              <a:gd name="adj" fmla="val 5172"/>
-            </a:avLst>
-          </a:prstGeom>
-          <a:solidFill>
-            <a:srgbClr val="0B1224"/>
-          </a:solidFill>
-          <a:ln w="25400">
-            <a:solidFill>
-              <a:srgbClr val="22C55E"/>
-            </a:solidFill>
-            <a:prstDash val="solid"/>
-          </a:ln>
-        </p:spPr>
-      </p:sp>
-      <p:sp>
-        <p:nvSpPr>
-          <p:cNvPr id="18" name="Shape 16"/>
-          <p:cNvSpPr/>
-          <p:nvPr/>
-        </p:nvSpPr>
-        <p:spPr>
-          <a:xfrm>
-            <a:off x="5029200" y="3017520"/>
-            <a:ext cx="457200" cy="457200"/>
-          </a:xfrm>
-          <a:prstGeom prst="ellipse">
-            <a:avLst/>
-          </a:prstGeom>
-          <a:solidFill>
-            <a:srgbClr val="22C55E">
-              <a:alpha val="30000"/>
-            </a:srgbClr>
-          </a:solidFill>
-          <a:ln w="12700">
-            <a:solidFill>
-              <a:srgbClr val="22C55E"/>
-            </a:solidFill>
-            <a:prstDash val="solid"/>
-          </a:ln>
-        </p:spPr>
-      </p:sp>
-      <p:sp>
-        <p:nvSpPr>
-          <p:cNvPr id="19" name="Text 17"/>
-          <p:cNvSpPr/>
-          <p:nvPr/>
-        </p:nvSpPr>
-        <p:spPr>
-          <a:xfrm>
-            <a:off x="5623560" y="3017520"/>
-            <a:ext cx="2194560" cy="365760"/>
-          </a:xfrm>
-          <a:prstGeom prst="rect">
-            <a:avLst/>
-          </a:prstGeom>
-          <a:noFill/>
-          <a:ln/>
-        </p:spPr>
-        <p:txBody>
-          <a:bodyPr wrap="square" rtlCol="0" anchor="ctr"/>
-          <a:lstStyle/>
-          <a:p>
-            <a:pPr marL="0" indent="0">
-              <a:buNone/>
-            </a:pPr>
-            <a:r>
-              <a:rPr lang="en-US" sz="1600" b="1" dirty="0">
-                <a:solidFill>
-                  <a:srgbClr val="22C55E"/>
-                </a:solidFill>
-                <a:latin typeface="Consolas" pitchFamily="34" charset="0"/>
-                <a:ea typeface="Consolas" pitchFamily="34" charset="-122"/>
-                <a:cs typeface="Consolas" pitchFamily="34" charset="-120"/>
-              </a:rPr>
-              <a:t>mysql</a:t>
-            </a:r>
-            <a:endParaRPr lang="en-US" sz="1600" dirty="0"/>
-          </a:p>
-        </p:txBody>
-      </p:sp>
-      <p:sp>
-        <p:nvSpPr>
-          <p:cNvPr id="20" name="Text 18"/>
-          <p:cNvSpPr/>
-          <p:nvPr/>
-        </p:nvSpPr>
-        <p:spPr>
-          <a:xfrm>
-            <a:off x="5029200" y="3520440"/>
-            <a:ext cx="2743200" cy="274320"/>
-          </a:xfrm>
-          <a:prstGeom prst="rect">
-            <a:avLst/>
-          </a:prstGeom>
-          <a:noFill/>
-          <a:ln/>
-        </p:spPr>
-        <p:txBody>
-          <a:bodyPr wrap="square" rtlCol="0" anchor="ctr"/>
-          <a:lstStyle/>
-          <a:p>
-            <a:pPr marL="0" indent="0">
-              <a:buNone/>
-            </a:pPr>
-            <a:r>
-              <a:rPr lang="en-US" sz="1100" dirty="0">
-                <a:solidFill>
-                  <a:srgbClr val="E2E8F0"/>
-                </a:solidFill>
-                <a:latin typeface="Calibri" pitchFamily="34" charset="0"/>
-                <a:ea typeface="Calibri" pitchFamily="34" charset="-122"/>
-                <a:cs typeface="Calibri" pitchFamily="34" charset="-120"/>
-              </a:rPr>
-              <a:t>MySQL 8.0</a:t>
-            </a:r>
-            <a:endParaRPr lang="en-US" sz="1100" dirty="0"/>
-          </a:p>
-        </p:txBody>
-      </p:sp>
-      <p:sp>
-        <p:nvSpPr>
-          <p:cNvPr id="21" name="Text 19"/>
-          <p:cNvSpPr/>
-          <p:nvPr/>
-        </p:nvSpPr>
-        <p:spPr>
-          <a:xfrm>
-            <a:off x="5029200" y="3840480"/>
-            <a:ext cx="2743200" cy="1097280"/>
-          </a:xfrm>
-          <a:prstGeom prst="rect">
-            <a:avLst/>
-          </a:prstGeom>
-          <a:noFill/>
-          <a:ln/>
-        </p:spPr>
-        <p:txBody>
-          <a:bodyPr wrap="square" rtlCol="0" anchor="ctr"/>
-          <a:lstStyle/>
-          <a:p>
-            <a:pPr marL="0" indent="0">
-              <a:buNone/>
-            </a:pPr>
-            <a:r>
-              <a:rPr lang="en-US" sz="1100" dirty="0">
-                <a:solidFill>
-                  <a:srgbClr val="94A3B8"/>
-                </a:solidFill>
-                <a:latin typeface="Calibri" pitchFamily="34" charset="0"/>
-                <a:ea typeface="Calibri" pitchFamily="34" charset="-122"/>
-                <a:cs typeface="Calibri" pitchFamily="34" charset="-120"/>
-              </a:rPr>
-              <a:t>10 tablas:</a:t>
-            </a:r>
-            <a:endParaRPr lang="en-US" sz="1100" dirty="0"/>
-          </a:p>
-          <a:p>
-            <a:pPr marL="0" indent="0">
-              <a:buNone/>
-            </a:pPr>
-            <a:r>
-              <a:rPr lang="en-US" sz="1100" dirty="0">
-                <a:solidFill>
-                  <a:srgbClr val="94A3B8"/>
-                </a:solidFill>
-                <a:latin typeface="Calibri" pitchFamily="34" charset="0"/>
-                <a:ea typeface="Calibri" pitchFamily="34" charset="-122"/>
-                <a:cs typeface="Calibri" pitchFamily="34" charset="-120"/>
-              </a:rPr>
-              <a:t>usuarios, productos,</a:t>
-            </a:r>
-            <a:endParaRPr lang="en-US" sz="1100" dirty="0"/>
-          </a:p>
-          <a:p>
-            <a:pPr marL="0" indent="0">
-              <a:buNone/>
-            </a:pPr>
-            <a:r>
-              <a:rPr lang="en-US" sz="1100" dirty="0">
-                <a:solidFill>
-                  <a:srgbClr val="94A3B8"/>
-                </a:solidFill>
-                <a:latin typeface="Calibri" pitchFamily="34" charset="0"/>
-                <a:ea typeface="Calibri" pitchFamily="34" charset="-122"/>
-                <a:cs typeface="Calibri" pitchFamily="34" charset="-120"/>
-              </a:rPr>
-              <a:t>pedidos, métricas</a:t>
-            </a:r>
-            <a:endParaRPr lang="en-US" sz="1100" dirty="0"/>
-          </a:p>
-        </p:txBody>
-      </p:sp>
-      <p:sp>
-        <p:nvSpPr>
-          <p:cNvPr id="22" name="Text 20"/>
-          <p:cNvSpPr/>
-          <p:nvPr/>
-        </p:nvSpPr>
-        <p:spPr>
-          <a:xfrm>
-            <a:off x="5029200" y="5074920"/>
-            <a:ext cx="2743200" cy="274320"/>
-          </a:xfrm>
-          <a:prstGeom prst="rect">
-            <a:avLst/>
-          </a:prstGeom>
-          <a:noFill/>
-          <a:ln/>
-        </p:spPr>
-        <p:txBody>
-          <a:bodyPr wrap="square" rtlCol="0" anchor="ctr"/>
-          <a:lstStyle/>
-          <a:p>
-            <a:pPr marL="0" indent="0">
-              <a:buNone/>
-            </a:pPr>
-            <a:r>
-              <a:rPr lang="en-US" sz="1000" i="1" dirty="0">
-                <a:solidFill>
-                  <a:srgbClr val="22C55E"/>
-                </a:solidFill>
-                <a:latin typeface="Consolas" pitchFamily="34" charset="0"/>
-                <a:ea typeface="Consolas" pitchFamily="34" charset="-122"/>
-                <a:cs typeface="Consolas" pitchFamily="34" charset="-120"/>
-              </a:rPr>
-              <a:t>:3306 interno</a:t>
-            </a:r>
-            <a:endParaRPr lang="en-US" sz="1000" dirty="0"/>
-          </a:p>
-        </p:txBody>
-      </p:sp>
-      <p:sp>
-        <p:nvSpPr>
-          <p:cNvPr id="23" name="Shape 21"/>
-          <p:cNvSpPr/>
-          <p:nvPr/>
-        </p:nvSpPr>
-        <p:spPr>
-          <a:xfrm>
-            <a:off x="8595360" y="2834640"/>
-            <a:ext cx="3017520" cy="2651760"/>
-          </a:xfrm>
-          <a:prstGeom prst="roundRect">
-            <a:avLst>
-              <a:gd name="adj" fmla="val 5172"/>
-            </a:avLst>
-          </a:prstGeom>
-          <a:solidFill>
-            <a:srgbClr val="0B1224"/>
-          </a:solidFill>
-          <a:ln w="25400">
-            <a:solidFill>
-              <a:srgbClr val="8B5CF6"/>
-            </a:solidFill>
-            <a:prstDash val="solid"/>
-          </a:ln>
-        </p:spPr>
-      </p:sp>
-      <p:sp>
-        <p:nvSpPr>
-          <p:cNvPr id="24" name="Shape 22"/>
-          <p:cNvSpPr/>
-          <p:nvPr/>
-        </p:nvSpPr>
-        <p:spPr>
-          <a:xfrm>
-            <a:off x="8778240" y="3017520"/>
-            <a:ext cx="457200" cy="457200"/>
-          </a:xfrm>
-          <a:prstGeom prst="ellipse">
-            <a:avLst/>
-          </a:prstGeom>
-          <a:solidFill>
-            <a:srgbClr val="8B5CF6">
-              <a:alpha val="30000"/>
-            </a:srgbClr>
-          </a:solidFill>
-          <a:ln w="12700">
-            <a:solidFill>
-              <a:srgbClr val="8B5CF6"/>
-            </a:solidFill>
-            <a:prstDash val="solid"/>
-          </a:ln>
-        </p:spPr>
-      </p:sp>
-      <p:sp>
-        <p:nvSpPr>
-          <p:cNvPr id="25" name="Text 23"/>
-          <p:cNvSpPr/>
-          <p:nvPr/>
-        </p:nvSpPr>
-        <p:spPr>
-          <a:xfrm>
-            <a:off x="9372600" y="3017520"/>
-            <a:ext cx="2194560" cy="365760"/>
-          </a:xfrm>
-          <a:prstGeom prst="rect">
-            <a:avLst/>
-          </a:prstGeom>
-          <a:noFill/>
-          <a:ln/>
-        </p:spPr>
-        <p:txBody>
-          <a:bodyPr wrap="square" rtlCol="0" anchor="ctr"/>
-          <a:lstStyle/>
-          <a:p>
-            <a:pPr marL="0" indent="0">
-              <a:buNone/>
-            </a:pPr>
-            <a:r>
-              <a:rPr lang="en-US" sz="1600" b="1" dirty="0">
-                <a:solidFill>
-                  <a:srgbClr val="8B5CF6"/>
-                </a:solidFill>
-                <a:latin typeface="Consolas" pitchFamily="34" charset="0"/>
-                <a:ea typeface="Consolas" pitchFamily="34" charset="-122"/>
-                <a:cs typeface="Consolas" pitchFamily="34" charset="-120"/>
-              </a:rPr>
-              <a:t>monitor</a:t>
-            </a:r>
-            <a:endParaRPr lang="en-US" sz="1600" dirty="0"/>
-          </a:p>
-        </p:txBody>
-      </p:sp>
-      <p:sp>
-        <p:nvSpPr>
-          <p:cNvPr id="26" name="Text 24"/>
-          <p:cNvSpPr/>
-          <p:nvPr/>
-        </p:nvSpPr>
-        <p:spPr>
-          <a:xfrm>
-            <a:off x="8778240" y="3520440"/>
-            <a:ext cx="2743200" cy="274320"/>
-          </a:xfrm>
-          <a:prstGeom prst="rect">
-            <a:avLst/>
-          </a:prstGeom>
-          <a:noFill/>
-          <a:ln/>
-        </p:spPr>
-        <p:txBody>
-          <a:bodyPr wrap="square" rtlCol="0" anchor="ctr"/>
-          <a:lstStyle/>
-          <a:p>
-            <a:pPr marL="0" indent="0">
-              <a:buNone/>
-            </a:pPr>
-            <a:r>
-              <a:rPr lang="en-US" sz="1100" dirty="0">
-                <a:solidFill>
-                  <a:srgbClr val="E2E8F0"/>
-                </a:solidFill>
-                <a:latin typeface="Calibri" pitchFamily="34" charset="0"/>
-                <a:ea typeface="Calibri" pitchFamily="34" charset="-122"/>
-                <a:cs typeface="Calibri" pitchFamily="34" charset="-120"/>
-              </a:rPr>
-              <a:t>Python 3.11</a:t>
-            </a:r>
-            <a:endParaRPr lang="en-US" sz="1100" dirty="0"/>
-          </a:p>
-        </p:txBody>
-      </p:sp>
-      <p:sp>
-        <p:nvSpPr>
-          <p:cNvPr id="27" name="Text 25"/>
-          <p:cNvSpPr/>
-          <p:nvPr/>
-        </p:nvSpPr>
-        <p:spPr>
-          <a:xfrm>
-            <a:off x="8778240" y="3840480"/>
-            <a:ext cx="2743200" cy="1097280"/>
-          </a:xfrm>
-          <a:prstGeom prst="rect">
-            <a:avLst/>
-          </a:prstGeom>
-          <a:noFill/>
-          <a:ln/>
-        </p:spPr>
-        <p:txBody>
-          <a:bodyPr wrap="square" rtlCol="0" anchor="ctr"/>
-          <a:lstStyle/>
-          <a:p>
-            <a:pPr marL="0" indent="0">
-              <a:buNone/>
-            </a:pPr>
-            <a:r>
-              <a:rPr lang="en-US" sz="1100" dirty="0">
-                <a:solidFill>
-                  <a:srgbClr val="94A3B8"/>
-                </a:solidFill>
-                <a:latin typeface="Calibri" pitchFamily="34" charset="0"/>
-                <a:ea typeface="Calibri" pitchFamily="34" charset="-122"/>
-                <a:cs typeface="Calibri" pitchFamily="34" charset="-120"/>
-              </a:rPr>
-              <a:t>5 hilos POSIX</a:t>
-            </a:r>
-            <a:endParaRPr lang="en-US" sz="1100" dirty="0"/>
-          </a:p>
-          <a:p>
-            <a:pPr marL="0" indent="0">
-              <a:buNone/>
-            </a:pPr>
-            <a:r>
-              <a:rPr lang="en-US" sz="1100" dirty="0">
-                <a:solidFill>
-                  <a:srgbClr val="94A3B8"/>
-                </a:solidFill>
-                <a:latin typeface="Calibri" pitchFamily="34" charset="0"/>
-                <a:ea typeface="Calibri" pitchFamily="34" charset="-122"/>
-                <a:cs typeface="Calibri" pitchFamily="34" charset="-120"/>
-              </a:rPr>
-              <a:t>+ mutex</a:t>
-            </a:r>
-            <a:endParaRPr lang="en-US" sz="1100" dirty="0"/>
-          </a:p>
-          <a:p>
-            <a:pPr marL="0" indent="0">
-              <a:buNone/>
-            </a:pPr>
-            <a:r>
-              <a:rPr lang="en-US" sz="1100" dirty="0">
-                <a:solidFill>
-                  <a:srgbClr val="94A3B8"/>
-                </a:solidFill>
-                <a:latin typeface="Calibri" pitchFamily="34" charset="0"/>
-                <a:ea typeface="Calibri" pitchFamily="34" charset="-122"/>
-                <a:cs typeface="Calibri" pitchFamily="34" charset="-120"/>
-              </a:rPr>
-              <a:t>lee /proc del kernel</a:t>
-            </a:r>
-            <a:endParaRPr lang="en-US" sz="1100" dirty="0"/>
-          </a:p>
-        </p:txBody>
-      </p:sp>
-      <p:sp>
-        <p:nvSpPr>
-          <p:cNvPr id="28" name="Text 26"/>
-          <p:cNvSpPr/>
-          <p:nvPr/>
-        </p:nvSpPr>
-        <p:spPr>
-          <a:xfrm>
-            <a:off x="8778240" y="5074920"/>
-            <a:ext cx="2743200" cy="274320"/>
-          </a:xfrm>
-          <a:prstGeom prst="rect">
-            <a:avLst/>
-          </a:prstGeom>
-          <a:noFill/>
-          <a:ln/>
-        </p:spPr>
-        <p:txBody>
-          <a:bodyPr wrap="square" rtlCol="0" anchor="ctr"/>
-          <a:lstStyle/>
-          <a:p>
-            <a:pPr marL="0" indent="0">
-              <a:buNone/>
-            </a:pPr>
-            <a:r>
-              <a:rPr lang="en-US" sz="1000" i="1" dirty="0">
-                <a:solidFill>
-                  <a:srgbClr val="8B5CF6"/>
-                </a:solidFill>
-                <a:latin typeface="Consolas" pitchFamily="34" charset="0"/>
-                <a:ea typeface="Consolas" pitchFamily="34" charset="-122"/>
-                <a:cs typeface="Consolas" pitchFamily="34" charset="-120"/>
-              </a:rPr>
-              <a:t>sin puertos</a:t>
-            </a:r>
-            <a:endParaRPr lang="en-US" sz="1000" dirty="0"/>
-          </a:p>
-        </p:txBody>
-      </p:sp>
-      <p:sp>
-        <p:nvSpPr>
-          <p:cNvPr id="29" name="Text 27"/>
-          <p:cNvSpPr/>
-          <p:nvPr/>
-        </p:nvSpPr>
-        <p:spPr>
-          <a:xfrm>
-            <a:off x="457200" y="5989320"/>
-            <a:ext cx="11247120" cy="320040"/>
-          </a:xfrm>
-          <a:prstGeom prst="rect">
-            <a:avLst/>
-          </a:prstGeom>
-          <a:noFill/>
-          <a:ln/>
-        </p:spPr>
-        <p:txBody>
-          <a:bodyPr wrap="square" rtlCol="0" anchor="ctr"/>
-          <a:lstStyle/>
-          <a:p>
-            <a:pPr marL="0" indent="0" algn="ctr">
-              <a:buNone/>
-            </a:pPr>
-            <a:r>
-              <a:rPr lang="en-US" sz="1200" i="1" dirty="0">
-                <a:solidFill>
-                  <a:srgbClr val="F59E0B"/>
-                </a:solidFill>
-                <a:latin typeface="Consolas" pitchFamily="34" charset="0"/>
-                <a:ea typeface="Consolas" pitchFamily="34" charset="-122"/>
-                <a:cs typeface="Consolas" pitchFamily="34" charset="-120"/>
-              </a:rPr>
-              <a:t>/proc del host →  montado en read-only en el contenedor monitor</a:t>
-            </a:r>
-            <a:endParaRPr lang="en-US" sz="1200" dirty="0"/>
           </a:p>
         </p:txBody>
       </p:sp>

</xml_diff>